<commit_message>
Polish executive deck language for audience clarity
</commit_message>
<xml_diff>
--- a/docs/presentation/real-time-fraud-intelligence-console-executive-deck.pptx
+++ b/docs/presentation/real-time-fraud-intelligence-console-executive-deck.pptx
@@ -641,7 +641,7 @@
           <a:p/>
           <a:p>
             <a:r>
-              <a:t>The facade is the proposed integration architecture built on top of existing service boundaries. It is not yet implemented as a standalone endpoint.</a:t>
+              <a:t>The consolidated facade is the next integration layer over the existing scoring, case, investigation, workflow, reliability, and portfolio API surfaces.</a:t>
             </a:r>
           </a:p>
           <a:p/>
@@ -652,7 +652,7 @@
           </a:p>
           <a:p>
             <a:r>
-              <a:t>These are production hardening requirements. The architecture is documented in docs/INTEGRATION_API_BLUEPRINT.md.</a:t>
+              <a:t>The complete integration specification is in docs/INTEGRATION_API_BLUEPRINT.md.</a:t>
             </a:r>
           </a:p>
           <a:p/>
@@ -1712,7 +1712,7 @@
           <a:p/>
           <a:p>
             <a:r>
-              <a:t>No specific p95 latency value has been measured in the current build. This is architectural design reasoning, not load test output.</a:t>
+              <a:t>Latency design is based on current service topology and async path separation. Specific p95 values require load testing against a target infrastructure.</a:t>
             </a:r>
           </a:p>
         </p:txBody>
@@ -1793,7 +1793,7 @@
           </a:p>
           <a:p>
             <a:r>
-              <a:t>Stages 2-7 represent the architecture roadmap that current service boundaries support.</a:t>
+              <a:t>Stages 2 through 7 represent the architecture roadmap that current service boundaries support.</a:t>
             </a:r>
           </a:p>
           <a:p/>
@@ -1814,7 +1814,7 @@
           </a:p>
           <a:p>
             <a:r>
-              <a:t>Stage 4: Redis idempotency active at scale. API autoscales on queue depth.</a:t>
+              <a:t>Stage 4: Repeat request caching via Redis. API autoscales on queue depth.</a:t>
             </a:r>
           </a:p>
           <a:p>
@@ -1824,7 +1824,7 @@
           </a:p>
           <a:p>
             <a:r>
-              <a:t>Stage 6: Latency SLOs, score drift detection, AGENT_VERSION lineage, alerting.</a:t>
+              <a:t>Stage 6: Latency SLOs, score drift detection, agent version lineage tracking, alerting.</a:t>
             </a:r>
           </a:p>
           <a:p>
@@ -1835,13 +1835,13 @@
           <a:p/>
           <a:p>
             <a:r>
-              <a:t>This is not a claim of live 1M-user deployment. It is the scale path that current service boundaries make achievable with managed infrastructure.</a:t>
+              <a:t>The architecture separates fast scoring, async investigation, portfolio processing, and audit persistence so each layer can scale independently.</a:t>
             </a:r>
           </a:p>
           <a:p/>
           <a:p>
             <a:r>
-              <a:t>The architecture separates fast scoring, async investigation, portfolio processing, and audit persistence so each layer can scale independently.</a:t>
+              <a:t>This slide presents the scale architecture supported by current service boundaries. Each stage builds on the previous. Specific throughput targets require load testing against a target infrastructure.</a:t>
             </a:r>
           </a:p>
         </p:txBody>
@@ -6646,7 +6646,7 @@
                 </a:solidFill>
                 <a:latin typeface="Segoe UI"/>
               </a:rPr>
-              <a:t>Unified decision API over existing service boundaries</a:t>
+              <a:t>One API returns the full fraud decision package</a:t>
             </a:r>
           </a:p>
         </p:txBody>
@@ -7480,7 +7480,7 @@
                 </a:solidFill>
                 <a:latin typeface="Segoe UI"/>
               </a:rPr>
-              <a:t>Workflow event UUID</a:t>
+              <a:t>Audit event reference</a:t>
             </a:r>
           </a:p>
         </p:txBody>
@@ -9724,7 +9724,7 @@
                 </a:solidFill>
                 <a:latin typeface="Segoe UI"/>
               </a:rPr>
-              <a:t>Reason codes per layer. Inspectable.</a:t>
+              <a:t>Reason codes per layer. Fully traceable.</a:t>
             </a:r>
           </a:p>
         </p:txBody>
@@ -13125,7 +13125,7 @@
                 </a:solidFill>
                 <a:latin typeface="Segoe UI"/>
               </a:rPr>
-              <a:t>The console turns model output into a reviewable, evidence-led, analyst-controlled decision workflow.</a:t>
+              <a:t>The console connects model scores to analyst-controlled fraud decisions, with a full audit trail on every case.</a:t>
             </a:r>
           </a:p>
         </p:txBody>
@@ -14781,7 +14781,7 @@
                 </a:solidFill>
                 <a:latin typeface="Segoe UI"/>
               </a:rPr>
-              <a:t>Production-style local runtime  |  Each service boundary inspectable  |  Clear path to managed cloud equivalents</a:t>
+              <a:t>Production-style local runtime  |  Independent, inspectable services  |  Clear path to cloud equivalents</a:t>
             </a:r>
           </a:p>
         </p:txBody>
@@ -15727,7 +15727,7 @@
                 </a:solidFill>
                 <a:latin typeface="Segoe UI"/>
               </a:rPr>
-              <a:t>Analyst decision + audit write</a:t>
+              <a:t>Analyst decision. Audit trail updated.</a:t>
             </a:r>
           </a:p>
         </p:txBody>
@@ -16557,7 +16557,7 @@
                 </a:solidFill>
                 <a:latin typeface="Segoe UI"/>
               </a:rPr>
-              <a:t>Shared device, fan-in and fan-out</a:t>
+              <a:t>Shared devices and transaction flow patterns</a:t>
             </a:r>
           </a:p>
         </p:txBody>
@@ -16756,7 +16756,7 @@
                 </a:solidFill>
                 <a:latin typeface="Segoe UI"/>
               </a:rPr>
-              <a:t>Schema-validated. AGENT_VERSION tracked.</a:t>
+              <a:t>Validated output. Every brief version-tracked.</a:t>
             </a:r>
           </a:p>
         </p:txBody>
@@ -16912,7 +16912,7 @@
                 </a:solidFill>
                 <a:latin typeface="Segoe UI"/>
               </a:rPr>
-              <a:t>Required final action. Writes audit event.</a:t>
+              <a:t>Required final step. Updates the audit trail.</a:t>
             </a:r>
           </a:p>
         </p:txBody>
@@ -18288,7 +18288,7 @@
                 </a:solidFill>
                 <a:latin typeface="Segoe UI"/>
               </a:rPr>
-              <a:t>Full CSV never in API heap</a:t>
+              <a:t>Full CSV never loaded into API memory</a:t>
             </a:r>
           </a:p>
         </p:txBody>
@@ -18409,7 +18409,7 @@
                 </a:solidFill>
                 <a:latin typeface="Segoe UI"/>
               </a:rPr>
-              <a:t>Composite indexed pages</a:t>
+              <a:t>Indexed page queries</a:t>
             </a:r>
           </a:p>
         </p:txBody>
@@ -18565,7 +18565,7 @@
                 </a:solidFill>
                 <a:latin typeface="Segoe UI"/>
               </a:rPr>
-              <a:t>Cursor-streamed export</a:t>
+              <a:t>Streaming export</a:t>
             </a:r>
           </a:p>
         </p:txBody>
@@ -18600,7 +18600,7 @@
                 </a:solidFill>
                 <a:latin typeface="Segoe UI"/>
               </a:rPr>
-              <a:t>API memory flat across 1.64 GiB</a:t>
+              <a:t>API memory stays flat at 1.64 GiB output</a:t>
             </a:r>
           </a:p>
         </p:txBody>
@@ -18756,7 +18756,7 @@
                 </a:solidFill>
                 <a:latin typeface="Segoe UI"/>
               </a:rPr>
-              <a:t>Risk-tier filters + case promotion</a:t>
+              <a:t>Risk-tier filters and case promotion</a:t>
             </a:r>
           </a:p>
         </p:txBody>
@@ -20425,7 +20425,7 @@
                 </a:solidFill>
                 <a:latin typeface="Segoe UI"/>
               </a:rPr>
-              <a:t>Redis idempotency: request_id dedup, 24-hour TTL</a:t>
+              <a:t>Redis caching: Deduplicate repeat requests. 24-hour window.</a:t>
             </a:r>
           </a:p>
         </p:txBody>
@@ -20503,7 +20503,7 @@
                 </a:solidFill>
                 <a:latin typeface="Segoe UI"/>
               </a:rPr>
-              <a:t>Horizontal API workers: Stateless, CPU-bound, parallelisable</a:t>
+              <a:t>Horizontal API workers: Add capacity as request volume grows.</a:t>
             </a:r>
           </a:p>
         </p:txBody>
@@ -20581,7 +20581,7 @@
                 </a:solidFill>
                 <a:latin typeface="Segoe UI"/>
               </a:rPr>
-              <a:t>Independent consumers: Investigation and portfolio scale separately</a:t>
+              <a:t>Independent consumers: Investigation and portfolio scale separately.</a:t>
             </a:r>
           </a:p>
         </p:txBody>
@@ -21387,7 +21387,7 @@
                 </a:solidFill>
                 <a:latin typeface="Segoe UI"/>
               </a:rPr>
-              <a:t>Cache-backed idempotency at scale</a:t>
+              <a:t>Cached deduplication at scale</a:t>
             </a:r>
           </a:p>
         </p:txBody>

</xml_diff>